<commit_message>
Use application logo in latest deck
</commit_message>
<xml_diff>
--- a/decks/20260718_Obscura_Overview_PalantirGrade_FocusedMVP.pptx
+++ b/decks/20260718_Obscura_Overview_PalantirGrade_FocusedMVP.pptx
@@ -2622,48 +2622,33 @@
           </a:p>
         </p:txBody>
       </p:sp>
-      <p:sp>
-        <p:nvSpPr>
-          <p:cNvPr id="6" name="Text 3"/>
-          <p:cNvSpPr/>
-          <p:nvPr/>
-        </p:nvSpPr>
-        <p:spPr>
-          <a:xfrm>
-            <a:off x="10195560" y="320040"/>
-            <a:ext cx="1554480" cy="320040"/>
-          </a:xfrm>
-          <a:prstGeom prst="rect">
-            <a:avLst/>
-          </a:prstGeom>
-          <a:noFill/>
-          <a:ln/>
-        </p:spPr>
-        <p:txBody>
-          <a:bodyPr wrap="square" rtlCol="0" anchor="ctr"/>
-          <a:lstStyle/>
-          <a:p>
-            <a:pPr algn="r" indent="0" marL="0">
-              <a:buNone/>
-            </a:pPr>
-            <a:r>
-              <a:rPr lang="en-US" sz="1100" spc="300" kern="0" dirty="0">
-                <a:solidFill>
-                  <a:srgbClr val="FFFFFF"/>
-                </a:solidFill>
-                <a:latin typeface="Segoe UI Semibold" pitchFamily="34" charset="0"/>
-                <a:ea typeface="Segoe UI Semibold" pitchFamily="34" charset="-122"/>
-                <a:cs typeface="Segoe UI Semibold" pitchFamily="34" charset="-120"/>
-              </a:rPr>
-              <a:t>OBSCURA</a:t>
-            </a:r>
-            <a:endParaRPr lang="en-US" sz="1100" dirty="0"/>
-          </a:p>
-        </p:txBody>
-      </p:sp>
-      <p:sp>
-        <p:nvSpPr>
-          <p:cNvPr id="7" name="Shape 4"/>
+      <p:pic>
+        <p:nvPicPr>
+          <p:cNvPr id="6" name="Image 1" descr="../../public/logo.webp">    </p:cNvPr>
+          <p:cNvPicPr>
+            <a:picLocks noChangeAspect="1"/>
+          </p:cNvPicPr>
+          <p:nvPr/>
+        </p:nvPicPr>
+        <p:blipFill>
+          <a:blip r:embed="rId2"/>
+          <a:stretch>
+            <a:fillRect/>
+          </a:stretch>
+        </p:blipFill>
+        <p:spPr>
+          <a:xfrm>
+            <a:off x="6473952" y="384048"/>
+            <a:ext cx="621792" cy="621792"/>
+          </a:xfrm>
+          <a:prstGeom prst="rect">
+            <a:avLst/>
+          </a:prstGeom>
+        </p:spPr>
+      </p:pic>
+      <p:sp>
+        <p:nvSpPr>
+          <p:cNvPr id="7" name="Shape 3"/>
           <p:cNvSpPr/>
           <p:nvPr/>
         </p:nvSpPr>
@@ -2683,7 +2668,7 @@
       </p:sp>
       <p:sp>
         <p:nvSpPr>
-          <p:cNvPr id="8" name="Text 5"/>
+          <p:cNvPr id="8" name="Text 4"/>
           <p:cNvSpPr/>
           <p:nvPr/>
         </p:nvSpPr>
@@ -2742,7 +2727,7 @@
       </p:sp>
       <p:sp>
         <p:nvSpPr>
-          <p:cNvPr id="9" name="Text 6"/>
+          <p:cNvPr id="9" name="Text 5"/>
           <p:cNvSpPr/>
           <p:nvPr/>
         </p:nvSpPr>
@@ -2801,7 +2786,7 @@
       </p:sp>
       <p:sp>
         <p:nvSpPr>
-          <p:cNvPr id="10" name="Shape 7"/>
+          <p:cNvPr id="10" name="Shape 6"/>
           <p:cNvSpPr/>
           <p:nvPr/>
         </p:nvSpPr>
@@ -2821,7 +2806,7 @@
       </p:sp>
       <p:sp>
         <p:nvSpPr>
-          <p:cNvPr id="11" name="Shape 8"/>
+          <p:cNvPr id="11" name="Shape 7"/>
           <p:cNvSpPr/>
           <p:nvPr/>
         </p:nvSpPr>
@@ -2841,7 +2826,7 @@
       </p:sp>
       <p:sp>
         <p:nvSpPr>
-          <p:cNvPr id="12" name="Shape 9"/>
+          <p:cNvPr id="12" name="Shape 8"/>
           <p:cNvSpPr/>
           <p:nvPr/>
         </p:nvSpPr>
@@ -2861,7 +2846,7 @@
       </p:sp>
       <p:sp>
         <p:nvSpPr>
-          <p:cNvPr id="13" name="Text 10"/>
+          <p:cNvPr id="13" name="Text 9"/>
           <p:cNvSpPr/>
           <p:nvPr/>
         </p:nvSpPr>
@@ -2943,7 +2928,7 @@
       </p:sp>
       <p:sp>
         <p:nvSpPr>
-          <p:cNvPr id="14" name="Text 11"/>
+          <p:cNvPr id="14" name="Text 10"/>
           <p:cNvSpPr/>
           <p:nvPr/>
         </p:nvSpPr>
@@ -3025,7 +3010,7 @@
       </p:sp>
       <p:sp>
         <p:nvSpPr>
-          <p:cNvPr id="15" name="Text 12"/>
+          <p:cNvPr id="15" name="Text 11"/>
           <p:cNvSpPr/>
           <p:nvPr/>
         </p:nvSpPr>
@@ -12952,9 +12937,33 @@
           </a:p>
         </p:txBody>
       </p:sp>
-      <p:sp>
-        <p:nvSpPr>
-          <p:cNvPr id="4" name="Text 2"/>
+      <p:pic>
+        <p:nvPicPr>
+          <p:cNvPr id="4" name="Image 0" descr="../../public/brand-lockup.png">    </p:cNvPr>
+          <p:cNvPicPr>
+            <a:picLocks noChangeAspect="1"/>
+          </p:cNvPicPr>
+          <p:nvPr/>
+        </p:nvPicPr>
+        <p:blipFill>
+          <a:blip r:embed="rId1"/>
+          <a:stretch>
+            <a:fillRect/>
+          </a:stretch>
+        </p:blipFill>
+        <p:spPr>
+          <a:xfrm>
+            <a:off x="4224528" y="438912"/>
+            <a:ext cx="3749040" cy="987552"/>
+          </a:xfrm>
+          <a:prstGeom prst="rect">
+            <a:avLst/>
+          </a:prstGeom>
+        </p:spPr>
+      </p:pic>
+      <p:sp>
+        <p:nvSpPr>
+          <p:cNvPr id="5" name="Text 2"/>
           <p:cNvSpPr/>
           <p:nvPr/>
         </p:nvSpPr>
@@ -13010,7 +13019,7 @@
       </p:sp>
       <p:sp>
         <p:nvSpPr>
-          <p:cNvPr id="5" name="Text 3"/>
+          <p:cNvPr id="6" name="Text 3"/>
           <p:cNvSpPr/>
           <p:nvPr/>
         </p:nvSpPr>
@@ -13049,7 +13058,7 @@
       </p:sp>
       <p:sp>
         <p:nvSpPr>
-          <p:cNvPr id="6" name="Text 4"/>
+          <p:cNvPr id="7" name="Text 4"/>
           <p:cNvSpPr/>
           <p:nvPr/>
         </p:nvSpPr>
@@ -13088,7 +13097,7 @@
       </p:sp>
       <p:sp>
         <p:nvSpPr>
-          <p:cNvPr id="7" name="Text 5"/>
+          <p:cNvPr id="8" name="Text 5"/>
           <p:cNvSpPr/>
           <p:nvPr/>
         </p:nvSpPr>

</xml_diff>

<commit_message>
Tune deck logo sizing and placement
</commit_message>
<xml_diff>
--- a/decks/20260718_Obscura_Overview_PalantirGrade_FocusedMVP.pptx
+++ b/decks/20260718_Obscura_Overview_PalantirGrade_FocusedMVP.pptx
@@ -2521,110 +2521,9 @@
           <a:ln/>
         </p:spPr>
       </p:sp>
-      <p:sp>
-        <p:nvSpPr>
-          <p:cNvPr id="4" name="Text 1"/>
-          <p:cNvSpPr/>
-          <p:nvPr/>
-        </p:nvSpPr>
-        <p:spPr>
-          <a:xfrm>
-            <a:off x="457200" y="777240"/>
-            <a:ext cx="6583680" cy="2514600"/>
-          </a:xfrm>
-          <a:prstGeom prst="rect">
-            <a:avLst/>
-          </a:prstGeom>
-          <a:noFill/>
-          <a:ln/>
-        </p:spPr>
-        <p:txBody>
-          <a:bodyPr wrap="square" rtlCol="0" anchor="ctr"/>
-          <a:lstStyle/>
-          <a:p>
-            <a:pPr indent="0" marL="0">
-              <a:lnSpc>
-                <a:spcPts val="7200"/>
-              </a:lnSpc>
-              <a:buNone/>
-            </a:pPr>
-            <a:r>
-              <a:rPr lang="en-US" sz="6200" dirty="0">
-                <a:solidFill>
-                  <a:srgbClr val="FFFFFF"/>
-                </a:solidFill>
-                <a:latin typeface="Segoe UI Light" pitchFamily="34" charset="0"/>
-                <a:ea typeface="Segoe UI Light" pitchFamily="34" charset="-122"/>
-                <a:cs typeface="Segoe UI Light" pitchFamily="34" charset="-120"/>
-              </a:rPr>
-              <a:t>Obscura</a:t>
-            </a:r>
-            <a:endParaRPr lang="en-US" sz="6200" dirty="0"/>
-          </a:p>
-          <a:p>
-            <a:pPr indent="0" marL="0">
-              <a:lnSpc>
-                <a:spcPts val="7200"/>
-              </a:lnSpc>
-              <a:buNone/>
-            </a:pPr>
-            <a:r>
-              <a:rPr lang="en-US" sz="6200" dirty="0">
-                <a:solidFill>
-                  <a:srgbClr val="FFFFFF"/>
-                </a:solidFill>
-                <a:latin typeface="Segoe UI Light" pitchFamily="34" charset="0"/>
-                <a:ea typeface="Segoe UI Light" pitchFamily="34" charset="-122"/>
-                <a:cs typeface="Segoe UI Light" pitchFamily="34" charset="-120"/>
-              </a:rPr>
-              <a:t>Overview</a:t>
-            </a:r>
-            <a:endParaRPr lang="en-US" sz="6200" dirty="0"/>
-          </a:p>
-        </p:txBody>
-      </p:sp>
-      <p:sp>
-        <p:nvSpPr>
-          <p:cNvPr id="5" name="Text 2"/>
-          <p:cNvSpPr/>
-          <p:nvPr/>
-        </p:nvSpPr>
-        <p:spPr>
-          <a:xfrm>
-            <a:off x="502920" y="3429000"/>
-            <a:ext cx="6583680" cy="457200"/>
-          </a:xfrm>
-          <a:prstGeom prst="rect">
-            <a:avLst/>
-          </a:prstGeom>
-          <a:noFill/>
-          <a:ln/>
-        </p:spPr>
-        <p:txBody>
-          <a:bodyPr wrap="square" rtlCol="0" anchor="ctr"/>
-          <a:lstStyle/>
-          <a:p>
-            <a:pPr indent="0" marL="0">
-              <a:buNone/>
-            </a:pPr>
-            <a:r>
-              <a:rPr lang="en-US" sz="1800" dirty="0">
-                <a:solidFill>
-                  <a:srgbClr val="B9B9B4"/>
-                </a:solidFill>
-                <a:latin typeface="Arial" pitchFamily="34" charset="0"/>
-                <a:ea typeface="Arial" pitchFamily="34" charset="-122"/>
-                <a:cs typeface="Arial" pitchFamily="34" charset="-120"/>
-              </a:rPr>
-              <a:t>Private clinical AI on the clinic’s own laptop</a:t>
-            </a:r>
-            <a:endParaRPr lang="en-US" sz="1800" dirty="0"/>
-          </a:p>
-        </p:txBody>
-      </p:sp>
       <p:pic>
         <p:nvPicPr>
-          <p:cNvPr id="6" name="Image 1" descr="../../public/logo.webp">    </p:cNvPr>
+          <p:cNvPr id="4" name="Image 1" descr="../../public/brand-lockup.png">    </p:cNvPr>
           <p:cNvPicPr>
             <a:picLocks noChangeAspect="1"/>
           </p:cNvPicPr>
@@ -2638,14 +2537,115 @@
         </p:blipFill>
         <p:spPr>
           <a:xfrm>
-            <a:off x="6473952" y="384048"/>
-            <a:ext cx="621792" cy="621792"/>
+            <a:off x="438912" y="73152"/>
+            <a:ext cx="2331720" cy="1554480"/>
           </a:xfrm>
           <a:prstGeom prst="rect">
             <a:avLst/>
           </a:prstGeom>
         </p:spPr>
       </p:pic>
+      <p:sp>
+        <p:nvSpPr>
+          <p:cNvPr id="5" name="Text 1"/>
+          <p:cNvSpPr/>
+          <p:nvPr/>
+        </p:nvSpPr>
+        <p:spPr>
+          <a:xfrm>
+            <a:off x="457200" y="1170432"/>
+            <a:ext cx="6583680" cy="2148840"/>
+          </a:xfrm>
+          <a:prstGeom prst="rect">
+            <a:avLst/>
+          </a:prstGeom>
+          <a:noFill/>
+          <a:ln/>
+        </p:spPr>
+        <p:txBody>
+          <a:bodyPr wrap="square" rtlCol="0" anchor="ctr"/>
+          <a:lstStyle/>
+          <a:p>
+            <a:pPr indent="0" marL="0">
+              <a:lnSpc>
+                <a:spcPts val="7200"/>
+              </a:lnSpc>
+              <a:buNone/>
+            </a:pPr>
+            <a:r>
+              <a:rPr lang="en-US" sz="6200" dirty="0">
+                <a:solidFill>
+                  <a:srgbClr val="FFFFFF"/>
+                </a:solidFill>
+                <a:latin typeface="Segoe UI Light" pitchFamily="34" charset="0"/>
+                <a:ea typeface="Segoe UI Light" pitchFamily="34" charset="-122"/>
+                <a:cs typeface="Segoe UI Light" pitchFamily="34" charset="-120"/>
+              </a:rPr>
+              <a:t>Obscura</a:t>
+            </a:r>
+            <a:endParaRPr lang="en-US" sz="6200" dirty="0"/>
+          </a:p>
+          <a:p>
+            <a:pPr indent="0" marL="0">
+              <a:lnSpc>
+                <a:spcPts val="7200"/>
+              </a:lnSpc>
+              <a:buNone/>
+            </a:pPr>
+            <a:r>
+              <a:rPr lang="en-US" sz="6200" dirty="0">
+                <a:solidFill>
+                  <a:srgbClr val="FFFFFF"/>
+                </a:solidFill>
+                <a:latin typeface="Segoe UI Light" pitchFamily="34" charset="0"/>
+                <a:ea typeface="Segoe UI Light" pitchFamily="34" charset="-122"/>
+                <a:cs typeface="Segoe UI Light" pitchFamily="34" charset="-120"/>
+              </a:rPr>
+              <a:t>Overview</a:t>
+            </a:r>
+            <a:endParaRPr lang="en-US" sz="6200" dirty="0"/>
+          </a:p>
+        </p:txBody>
+      </p:sp>
+      <p:sp>
+        <p:nvSpPr>
+          <p:cNvPr id="6" name="Text 2"/>
+          <p:cNvSpPr/>
+          <p:nvPr/>
+        </p:nvSpPr>
+        <p:spPr>
+          <a:xfrm>
+            <a:off x="502920" y="3584448"/>
+            <a:ext cx="6583680" cy="457200"/>
+          </a:xfrm>
+          <a:prstGeom prst="rect">
+            <a:avLst/>
+          </a:prstGeom>
+          <a:noFill/>
+          <a:ln/>
+        </p:spPr>
+        <p:txBody>
+          <a:bodyPr wrap="square" rtlCol="0" anchor="ctr"/>
+          <a:lstStyle/>
+          <a:p>
+            <a:pPr indent="0" marL="0">
+              <a:buNone/>
+            </a:pPr>
+            <a:r>
+              <a:rPr lang="en-US" sz="1800" dirty="0">
+                <a:solidFill>
+                  <a:srgbClr val="B9B9B4"/>
+                </a:solidFill>
+                <a:latin typeface="Arial" pitchFamily="34" charset="0"/>
+                <a:ea typeface="Arial" pitchFamily="34" charset="-122"/>
+                <a:cs typeface="Arial" pitchFamily="34" charset="-120"/>
+              </a:rPr>
+              <a:t>Private clinical AI on the clinic’s own laptop</a:t>
+            </a:r>
+            <a:endParaRPr lang="en-US" sz="1800" dirty="0"/>
+          </a:p>
+        </p:txBody>
+      </p:sp>
       <p:sp>
         <p:nvSpPr>
           <p:cNvPr id="7" name="Shape 3"/>
@@ -12953,8 +12953,8 @@
         </p:blipFill>
         <p:spPr>
           <a:xfrm>
-            <a:off x="4224528" y="438912"/>
-            <a:ext cx="3749040" cy="987552"/>
+            <a:off x="3977640" y="18288"/>
+            <a:ext cx="4251960" cy="2423160"/>
           </a:xfrm>
           <a:prstGeom prst="rect">
             <a:avLst/>
@@ -12969,7 +12969,7 @@
         </p:nvSpPr>
         <p:spPr>
           <a:xfrm>
-            <a:off x="502920" y="2286000"/>
+            <a:off x="502920" y="2578608"/>
             <a:ext cx="11183112" cy="1554480"/>
           </a:xfrm>
           <a:prstGeom prst="rect">
@@ -13025,7 +13025,7 @@
         </p:nvSpPr>
         <p:spPr>
           <a:xfrm>
-            <a:off x="502920" y="3977640"/>
+            <a:off x="502920" y="4251960"/>
             <a:ext cx="11183112" cy="457200"/>
           </a:xfrm>
           <a:prstGeom prst="rect">

</xml_diff>